<commit_message>
Focus workshop overview on three systems without portal
</commit_message>
<xml_diff>
--- a/presentation/BM_Workshop_01-04_v2.pptx
+++ b/presentation/BM_Workshop_01-04_v2.pptx
@@ -505,7 +505,7 @@
           <a:lstStyle/>
           <a:p>
             <a:r>
-              <a:t>첫 장은 전체 발표의 안내도입니다. 이번 해커톤의 결과물은 new_meal(식사 신청), receipt(법인카드 영수증 관리), permit(현장 출입 신청)의 세 가지 시스템입니다. AURORA 포털은 이 시스템들을 연결하는 통합 접속 창구로 소개합니다. 포털의 공통 로그인, 시스템 간 데이터 자동 통합, ERP 자동 전표 연동을 구현했다는 뜻은 아닙니다. Cloud Vision과 Vertex AI 기반 자동 판독은 영수증 시스템 기능이며 식사·출입 시스템에도 AI 판독이 적용된 것으로 표현하지 않습니다. 세 결과물은 포털 소스의 연결 메뉴와 사용자가 첨부한 Codex 프로젝트 목록을 기준으로 정리했습니다. 식사·출입 시스템의 상세 내부 승인 기능은 확인하지 않아 기재하지 않았습니다. 효과는 추진 목적과 기대효과이며 시간 절감률은 실측하지 않았습니다. 2~4페이지는 기존 영수증 관리 설명으로 이어집니다.</a:t>
+              <a:t>첫 장은 전체 발표의 안내도입니다. 이번 해커톤의 결과물은 new_meal(식사 신청), receipt(법인카드 영수증 관리), permit(현장 출입 신청)의 세 가지 시스템입니다. 포털은 참고 자료이며 발표 내용에 포함하지 않습니다. 포털의 공통 로그인, 시스템 간 데이터 자동 통합, ERP 자동 전표 연동을 구현했다는 뜻은 아닙니다. Cloud Vision과 Vertex AI 기반 자동 판독은 영수증 시스템 기능이며 식사·출입 시스템에도 AI 판독이 적용된 것으로 표현하지 않습니다. 세 결과물은 포털 소스의 연결 메뉴와 사용자가 첨부한 Codex 프로젝트 목록을 기준으로 정리했습니다. 식사·출입 시스템의 상세 내부 승인 기능은 확인하지 않아 기재하지 않았습니다. 효과는 추진 목적과 기대효과이며 시간 절감률은 실측하지 않았습니다. 2~4페이지는 기존 영수증 관리 설명으로 이어집니다.</a:t>
             </a:r>
           </a:p>
         </p:txBody>
@@ -5070,7 +5070,7 @@
               </a:defRPr>
             </a:pPr>
             <a:r>
-              <a:t>AURORA 포털에서 한 번에 접속  →  직원은 직접 기록 · 관리팀은 확인과 처리 · BM은 판단과 현장 지원</a:t>
+              <a:t>직원은 한 번에 기록  →  관리팀은 확인·처리에 집중  →  BM은 판단과 현장 지원에 집중</a:t>
             </a:r>
           </a:p>
         </p:txBody>

</xml_diff>